<commit_message>
Switch presentation to light theme
</commit_message>
<xml_diff>
--- a/presentation_forex_pipeline.pptx
+++ b/presentation_forex_pipeline.pptx
@@ -3093,7 +3093,7 @@
     <p:bg>
       <p:bgPr>
         <a:solidFill>
-          <a:srgbClr val="1A1A2E"/>
+          <a:srgbClr val="FFFFFF"/>
         </a:solidFill>
         <a:effectLst/>
       </p:bgPr>
@@ -3120,7 +3120,7 @@
             <a:avLst/>
           </a:prstGeom>
           <a:solidFill>
-            <a:srgbClr val="006DAA"/>
+            <a:srgbClr val="1565C0"/>
           </a:solidFill>
           <a:ln>
             <a:noFill/>
@@ -3163,7 +3163,7 @@
             <a:avLst/>
           </a:prstGeom>
           <a:solidFill>
-            <a:srgbClr val="006DAA"/>
+            <a:srgbClr val="1565C0"/>
           </a:solidFill>
           <a:ln>
             <a:noFill/>
@@ -3216,7 +3216,7 @@
             <a:pPr algn="l">
               <a:defRPr sz="4000" b="1">
                 <a:solidFill>
-                  <a:srgbClr val="FFFFFF"/>
+                  <a:srgbClr val="1565C0"/>
                 </a:solidFill>
               </a:defRPr>
             </a:pPr>
@@ -3251,7 +3251,7 @@
             <a:pPr algn="l">
               <a:defRPr sz="2200" b="0">
                 <a:solidFill>
-                  <a:srgbClr val="006DAA"/>
+                  <a:srgbClr val="1565C0"/>
                 </a:solidFill>
               </a:defRPr>
             </a:pPr>
@@ -3329,7 +3329,7 @@
             <a:pPr algn="l">
               <a:defRPr sz="1800" b="0">
                 <a:solidFill>
-                  <a:srgbClr val="666666"/>
+                  <a:srgbClr val="555555"/>
                 </a:solidFill>
               </a:defRPr>
             </a:pPr>
@@ -3364,7 +3364,7 @@
             <a:pPr algn="l">
               <a:defRPr sz="1800" b="0">
                 <a:solidFill>
-                  <a:srgbClr val="666666"/>
+                  <a:srgbClr val="555555"/>
                 </a:solidFill>
               </a:defRPr>
             </a:pPr>
@@ -3399,7 +3399,7 @@
             <a:pPr algn="l">
               <a:defRPr sz="1600" b="0">
                 <a:solidFill>
-                  <a:srgbClr val="666666"/>
+                  <a:srgbClr val="555555"/>
                 </a:solidFill>
               </a:defRPr>
             </a:pPr>
@@ -3423,7 +3423,7 @@
     <p:bg>
       <p:bgPr>
         <a:solidFill>
-          <a:srgbClr val="1A1A2E"/>
+          <a:srgbClr val="FFFFFF"/>
         </a:solidFill>
         <a:effectLst/>
       </p:bgPr>
@@ -3450,7 +3450,7 @@
             <a:avLst/>
           </a:prstGeom>
           <a:solidFill>
-            <a:srgbClr val="006DAA"/>
+            <a:srgbClr val="1565C0"/>
           </a:solidFill>
           <a:ln>
             <a:noFill/>
@@ -3493,7 +3493,7 @@
             <a:avLst/>
           </a:prstGeom>
           <a:solidFill>
-            <a:srgbClr val="006DAA"/>
+            <a:srgbClr val="1565C0"/>
           </a:solidFill>
           <a:ln>
             <a:noFill/>
@@ -3546,7 +3546,7 @@
             <a:pPr algn="l">
               <a:defRPr sz="3200" b="1">
                 <a:solidFill>
-                  <a:srgbClr val="FFFFFF"/>
+                  <a:srgbClr val="1565C0"/>
                 </a:solidFill>
               </a:defRPr>
             </a:pPr>
@@ -3571,7 +3571,7 @@
             <a:avLst/>
           </a:prstGeom>
           <a:solidFill>
-            <a:srgbClr val="006DAA"/>
+            <a:srgbClr val="1565C0"/>
           </a:solidFill>
           <a:ln>
             <a:noFill/>
@@ -3624,7 +3624,7 @@
             <a:pPr algn="r">
               <a:defRPr sz="1200" b="0">
                 <a:solidFill>
-                  <a:srgbClr val="666666"/>
+                  <a:srgbClr val="555555"/>
                 </a:solidFill>
               </a:defRPr>
             </a:pPr>
@@ -3662,7 +3662,7 @@
               </a:spcAft>
               <a:defRPr sz="2000">
                 <a:solidFill>
-                  <a:srgbClr val="FFFFFF"/>
+                  <a:srgbClr val="1A1A2E"/>
                 </a:solidFill>
               </a:defRPr>
             </a:pPr>
@@ -3677,7 +3677,7 @@
               </a:spcAft>
               <a:defRPr sz="2000">
                 <a:solidFill>
-                  <a:srgbClr val="FFFFFF"/>
+                  <a:srgbClr val="1A1A2E"/>
                 </a:solidFill>
               </a:defRPr>
             </a:pPr>
@@ -3689,7 +3689,7 @@
               </a:spcAft>
               <a:defRPr sz="2000">
                 <a:solidFill>
-                  <a:srgbClr val="FFFFFF"/>
+                  <a:srgbClr val="1A1A2E"/>
                 </a:solidFill>
               </a:defRPr>
             </a:pPr>
@@ -3704,7 +3704,7 @@
               </a:spcAft>
               <a:defRPr sz="2000">
                 <a:solidFill>
-                  <a:srgbClr val="FFFFFF"/>
+                  <a:srgbClr val="1A1A2E"/>
                 </a:solidFill>
               </a:defRPr>
             </a:pPr>
@@ -3716,7 +3716,7 @@
               </a:spcAft>
               <a:defRPr sz="2000">
                 <a:solidFill>
-                  <a:srgbClr val="FFFFFF"/>
+                  <a:srgbClr val="1A1A2E"/>
                 </a:solidFill>
               </a:defRPr>
             </a:pPr>
@@ -3731,7 +3731,7 @@
               </a:spcAft>
               <a:defRPr sz="2000">
                 <a:solidFill>
-                  <a:srgbClr val="FFFFFF"/>
+                  <a:srgbClr val="1A1A2E"/>
                 </a:solidFill>
               </a:defRPr>
             </a:pPr>
@@ -3743,7 +3743,7 @@
               </a:spcAft>
               <a:defRPr sz="2000">
                 <a:solidFill>
-                  <a:srgbClr val="FFFFFF"/>
+                  <a:srgbClr val="1A1A2E"/>
                 </a:solidFill>
               </a:defRPr>
             </a:pPr>
@@ -3758,7 +3758,7 @@
               </a:spcAft>
               <a:defRPr sz="2000">
                 <a:solidFill>
-                  <a:srgbClr val="FFFFFF"/>
+                  <a:srgbClr val="1A1A2E"/>
                 </a:solidFill>
               </a:defRPr>
             </a:pPr>
@@ -3770,7 +3770,7 @@
               </a:spcAft>
               <a:defRPr sz="2000">
                 <a:solidFill>
-                  <a:srgbClr val="FFFFFF"/>
+                  <a:srgbClr val="1A1A2E"/>
                 </a:solidFill>
               </a:defRPr>
             </a:pPr>
@@ -3785,7 +3785,7 @@
               </a:spcAft>
               <a:defRPr sz="2000">
                 <a:solidFill>
-                  <a:srgbClr val="FFFFFF"/>
+                  <a:srgbClr val="1A1A2E"/>
                 </a:solidFill>
               </a:defRPr>
             </a:pPr>
@@ -3797,7 +3797,7 @@
               </a:spcAft>
               <a:defRPr sz="2000">
                 <a:solidFill>
-                  <a:srgbClr val="FFFFFF"/>
+                  <a:srgbClr val="1A1A2E"/>
                 </a:solidFill>
               </a:defRPr>
             </a:pPr>
@@ -3856,7 +3856,7 @@
     <p:bg>
       <p:bgPr>
         <a:solidFill>
-          <a:srgbClr val="1A1A2E"/>
+          <a:srgbClr val="FFFFFF"/>
         </a:solidFill>
         <a:effectLst/>
       </p:bgPr>
@@ -3893,7 +3893,7 @@
             <a:pPr algn="l">
               <a:defRPr sz="3200" b="1">
                 <a:solidFill>
-                  <a:srgbClr val="FFFFFF"/>
+                  <a:srgbClr val="1565C0"/>
                 </a:solidFill>
               </a:defRPr>
             </a:pPr>
@@ -3918,7 +3918,7 @@
             <a:avLst/>
           </a:prstGeom>
           <a:solidFill>
-            <a:srgbClr val="006DAA"/>
+            <a:srgbClr val="1565C0"/>
           </a:solidFill>
           <a:ln>
             <a:noFill/>
@@ -4023,7 +4023,7 @@
             <a:pPr algn="r">
               <a:defRPr sz="1200" b="0">
                 <a:solidFill>
-                  <a:srgbClr val="666666"/>
+                  <a:srgbClr val="555555"/>
                 </a:solidFill>
               </a:defRPr>
             </a:pPr>
@@ -4061,7 +4061,7 @@
               </a:spcAft>
               <a:defRPr sz="2000">
                 <a:solidFill>
-                  <a:srgbClr val="FFFFFF"/>
+                  <a:srgbClr val="1A1A2E"/>
                 </a:solidFill>
               </a:defRPr>
             </a:pPr>
@@ -4076,7 +4076,7 @@
               </a:spcAft>
               <a:defRPr sz="2000">
                 <a:solidFill>
-                  <a:srgbClr val="FFFFFF"/>
+                  <a:srgbClr val="1A1A2E"/>
                 </a:solidFill>
               </a:defRPr>
             </a:pPr>
@@ -4091,7 +4091,7 @@
               </a:spcAft>
               <a:defRPr sz="2000">
                 <a:solidFill>
-                  <a:srgbClr val="FFFFFF"/>
+                  <a:srgbClr val="1A1A2E"/>
                 </a:solidFill>
               </a:defRPr>
             </a:pPr>
@@ -4106,7 +4106,7 @@
               </a:spcAft>
               <a:defRPr sz="2000">
                 <a:solidFill>
-                  <a:srgbClr val="FFFFFF"/>
+                  <a:srgbClr val="1A1A2E"/>
                 </a:solidFill>
               </a:defRPr>
             </a:pPr>
@@ -4118,7 +4118,7 @@
               </a:spcAft>
               <a:defRPr sz="2000">
                 <a:solidFill>
-                  <a:srgbClr val="FFFFFF"/>
+                  <a:srgbClr val="1A1A2E"/>
                 </a:solidFill>
               </a:defRPr>
             </a:pPr>
@@ -4133,7 +4133,7 @@
               </a:spcAft>
               <a:defRPr sz="2000">
                 <a:solidFill>
-                  <a:srgbClr val="FFFFFF"/>
+                  <a:srgbClr val="1A1A2E"/>
                 </a:solidFill>
               </a:defRPr>
             </a:pPr>
@@ -4145,7 +4145,7 @@
               </a:spcAft>
               <a:defRPr sz="2000">
                 <a:solidFill>
-                  <a:srgbClr val="FFFFFF"/>
+                  <a:srgbClr val="1A1A2E"/>
                 </a:solidFill>
               </a:defRPr>
             </a:pPr>
@@ -4160,7 +4160,7 @@
               </a:spcAft>
               <a:defRPr sz="2000">
                 <a:solidFill>
-                  <a:srgbClr val="FFFFFF"/>
+                  <a:srgbClr val="1A1A2E"/>
                 </a:solidFill>
               </a:defRPr>
             </a:pPr>
@@ -4175,7 +4175,7 @@
               </a:spcAft>
               <a:defRPr sz="2000">
                 <a:solidFill>
-                  <a:srgbClr val="FFFFFF"/>
+                  <a:srgbClr val="1A1A2E"/>
                 </a:solidFill>
               </a:defRPr>
             </a:pPr>
@@ -4187,7 +4187,7 @@
               </a:spcAft>
               <a:defRPr sz="2000">
                 <a:solidFill>
-                  <a:srgbClr val="FFFFFF"/>
+                  <a:srgbClr val="1A1A2E"/>
                 </a:solidFill>
               </a:defRPr>
             </a:pPr>
@@ -4202,7 +4202,7 @@
               </a:spcAft>
               <a:defRPr sz="2000">
                 <a:solidFill>
-                  <a:srgbClr val="FFFFFF"/>
+                  <a:srgbClr val="1A1A2E"/>
                 </a:solidFill>
               </a:defRPr>
             </a:pPr>
@@ -4214,7 +4214,7 @@
               </a:spcAft>
               <a:defRPr sz="2000">
                 <a:solidFill>
-                  <a:srgbClr val="FFFFFF"/>
+                  <a:srgbClr val="1A1A2E"/>
                 </a:solidFill>
               </a:defRPr>
             </a:pPr>
@@ -4229,7 +4229,7 @@
               </a:spcAft>
               <a:defRPr sz="2000">
                 <a:solidFill>
-                  <a:srgbClr val="FFFFFF"/>
+                  <a:srgbClr val="1A1A2E"/>
                 </a:solidFill>
               </a:defRPr>
             </a:pPr>
@@ -4253,7 +4253,7 @@
     <p:bg>
       <p:bgPr>
         <a:solidFill>
-          <a:srgbClr val="1A1A2E"/>
+          <a:srgbClr val="FFFFFF"/>
         </a:solidFill>
         <a:effectLst/>
       </p:bgPr>
@@ -4290,7 +4290,7 @@
             <a:pPr algn="l">
               <a:defRPr sz="3200" b="1">
                 <a:solidFill>
-                  <a:srgbClr val="FFFFFF"/>
+                  <a:srgbClr val="1565C0"/>
                 </a:solidFill>
               </a:defRPr>
             </a:pPr>
@@ -4315,7 +4315,7 @@
             <a:avLst/>
           </a:prstGeom>
           <a:solidFill>
-            <a:srgbClr val="006DAA"/>
+            <a:srgbClr val="1565C0"/>
           </a:solidFill>
           <a:ln>
             <a:noFill/>
@@ -4420,7 +4420,7 @@
             <a:pPr algn="r">
               <a:defRPr sz="1200" b="0">
                 <a:solidFill>
-                  <a:srgbClr val="666666"/>
+                  <a:srgbClr val="555555"/>
                 </a:solidFill>
               </a:defRPr>
             </a:pPr>
@@ -4445,7 +4445,7 @@
             <a:avLst/>
           </a:prstGeom>
           <a:solidFill>
-            <a:srgbClr val="006DAA"/>
+            <a:srgbClr val="1565C0"/>
           </a:solidFill>
           <a:ln>
             <a:noFill/>
@@ -4775,7 +4775,7 @@
             <a:pPr algn="l">
               <a:defRPr sz="1400" b="0">
                 <a:solidFill>
-                  <a:srgbClr val="666666"/>
+                  <a:srgbClr val="555555"/>
                 </a:solidFill>
               </a:defRPr>
             </a:pPr>
@@ -4799,7 +4799,7 @@
     <p:bg>
       <p:bgPr>
         <a:solidFill>
-          <a:srgbClr val="1A1A2E"/>
+          <a:srgbClr val="FFFFFF"/>
         </a:solidFill>
         <a:effectLst/>
       </p:bgPr>
@@ -4836,7 +4836,7 @@
             <a:pPr algn="l">
               <a:defRPr sz="3200" b="1">
                 <a:solidFill>
-                  <a:srgbClr val="FFFFFF"/>
+                  <a:srgbClr val="1565C0"/>
                 </a:solidFill>
               </a:defRPr>
             </a:pPr>
@@ -4861,7 +4861,7 @@
             <a:avLst/>
           </a:prstGeom>
           <a:solidFill>
-            <a:srgbClr val="006DAA"/>
+            <a:srgbClr val="1565C0"/>
           </a:solidFill>
           <a:ln>
             <a:noFill/>
@@ -4966,7 +4966,7 @@
             <a:pPr algn="r">
               <a:defRPr sz="1200" b="0">
                 <a:solidFill>
-                  <a:srgbClr val="666666"/>
+                  <a:srgbClr val="555555"/>
                 </a:solidFill>
               </a:defRPr>
             </a:pPr>
@@ -5001,7 +5001,7 @@
             <a:pPr algn="l">
               <a:defRPr sz="1800" b="0">
                 <a:solidFill>
-                  <a:srgbClr val="666666"/>
+                  <a:srgbClr val="555555"/>
                 </a:solidFill>
               </a:defRPr>
             </a:pPr>
@@ -5026,7 +5026,7 @@
             <a:avLst/>
           </a:prstGeom>
           <a:solidFill>
-            <a:srgbClr val="006DAA"/>
+            <a:srgbClr val="1565C0"/>
           </a:solidFill>
           <a:ln>
             <a:noFill/>
@@ -5090,7 +5090,7 @@
             <a:avLst/>
           </a:prstGeom>
           <a:solidFill>
-            <a:srgbClr val="006DAA"/>
+            <a:srgbClr val="1565C0"/>
           </a:solidFill>
           <a:ln>
             <a:noFill/>
@@ -5154,7 +5154,7 @@
             <a:avLst/>
           </a:prstGeom>
           <a:solidFill>
-            <a:srgbClr val="006DAA"/>
+            <a:srgbClr val="1565C0"/>
           </a:solidFill>
           <a:ln>
             <a:noFill/>
@@ -5484,7 +5484,7 @@
             <a:pPr algn="l">
               <a:defRPr sz="1600" b="0">
                 <a:solidFill>
-                  <a:srgbClr val="666666"/>
+                  <a:srgbClr val="555555"/>
                 </a:solidFill>
               </a:defRPr>
             </a:pPr>
@@ -5516,7 +5516,7 @@
     <p:bg>
       <p:bgPr>
         <a:solidFill>
-          <a:srgbClr val="1A1A2E"/>
+          <a:srgbClr val="FFFFFF"/>
         </a:solidFill>
         <a:effectLst/>
       </p:bgPr>
@@ -5553,7 +5553,7 @@
             <a:pPr algn="l">
               <a:defRPr sz="3200" b="1">
                 <a:solidFill>
-                  <a:srgbClr val="FFFFFF"/>
+                  <a:srgbClr val="1565C0"/>
                 </a:solidFill>
               </a:defRPr>
             </a:pPr>
@@ -5578,7 +5578,7 @@
             <a:avLst/>
           </a:prstGeom>
           <a:solidFill>
-            <a:srgbClr val="006DAA"/>
+            <a:srgbClr val="1565C0"/>
           </a:solidFill>
           <a:ln>
             <a:noFill/>
@@ -5683,7 +5683,7 @@
             <a:pPr algn="r">
               <a:defRPr sz="1200" b="0">
                 <a:solidFill>
-                  <a:srgbClr val="666666"/>
+                  <a:srgbClr val="555555"/>
                 </a:solidFill>
               </a:defRPr>
             </a:pPr>
@@ -5721,7 +5721,7 @@
               </a:spcAft>
               <a:defRPr sz="1700">
                 <a:solidFill>
-                  <a:srgbClr val="FFFFFF"/>
+                  <a:srgbClr val="1A1A2E"/>
                 </a:solidFill>
               </a:defRPr>
             </a:pPr>
@@ -5736,7 +5736,7 @@
               </a:spcAft>
               <a:defRPr sz="1700">
                 <a:solidFill>
-                  <a:srgbClr val="FFFFFF"/>
+                  <a:srgbClr val="1A1A2E"/>
                 </a:solidFill>
               </a:defRPr>
             </a:pPr>
@@ -5748,7 +5748,7 @@
               </a:spcAft>
               <a:defRPr sz="1700">
                 <a:solidFill>
-                  <a:srgbClr val="FFFFFF"/>
+                  <a:srgbClr val="1A1A2E"/>
                 </a:solidFill>
               </a:defRPr>
             </a:pPr>
@@ -5763,7 +5763,7 @@
               </a:spcAft>
               <a:defRPr sz="1700">
                 <a:solidFill>
-                  <a:srgbClr val="FFFFFF"/>
+                  <a:srgbClr val="1A1A2E"/>
                 </a:solidFill>
               </a:defRPr>
             </a:pPr>
@@ -5775,7 +5775,7 @@
               </a:spcAft>
               <a:defRPr sz="1700">
                 <a:solidFill>
-                  <a:srgbClr val="FFFFFF"/>
+                  <a:srgbClr val="1A1A2E"/>
                 </a:solidFill>
               </a:defRPr>
             </a:pPr>
@@ -5790,7 +5790,7 @@
               </a:spcAft>
               <a:defRPr sz="1700">
                 <a:solidFill>
-                  <a:srgbClr val="FFFFFF"/>
+                  <a:srgbClr val="1A1A2E"/>
                 </a:solidFill>
               </a:defRPr>
             </a:pPr>
@@ -5802,7 +5802,7 @@
               </a:spcAft>
               <a:defRPr sz="1700">
                 <a:solidFill>
-                  <a:srgbClr val="FFFFFF"/>
+                  <a:srgbClr val="1A1A2E"/>
                 </a:solidFill>
               </a:defRPr>
             </a:pPr>
@@ -5817,7 +5817,7 @@
               </a:spcAft>
               <a:defRPr sz="1700">
                 <a:solidFill>
-                  <a:srgbClr val="FFFFFF"/>
+                  <a:srgbClr val="1A1A2E"/>
                 </a:solidFill>
               </a:defRPr>
             </a:pPr>
@@ -5829,7 +5829,7 @@
               </a:spcAft>
               <a:defRPr sz="1700">
                 <a:solidFill>
-                  <a:srgbClr val="FFFFFF"/>
+                  <a:srgbClr val="1A1A2E"/>
                 </a:solidFill>
               </a:defRPr>
             </a:pPr>
@@ -5844,7 +5844,7 @@
               </a:spcAft>
               <a:defRPr sz="1700">
                 <a:solidFill>
-                  <a:srgbClr val="FFFFFF"/>
+                  <a:srgbClr val="1A1A2E"/>
                 </a:solidFill>
               </a:defRPr>
             </a:pPr>
@@ -5856,7 +5856,7 @@
               </a:spcAft>
               <a:defRPr sz="1700">
                 <a:solidFill>
-                  <a:srgbClr val="FFFFFF"/>
+                  <a:srgbClr val="1A1A2E"/>
                 </a:solidFill>
               </a:defRPr>
             </a:pPr>
@@ -5871,7 +5871,7 @@
               </a:spcAft>
               <a:defRPr sz="1700">
                 <a:solidFill>
-                  <a:srgbClr val="FFFFFF"/>
+                  <a:srgbClr val="1A1A2E"/>
                 </a:solidFill>
               </a:defRPr>
             </a:pPr>
@@ -5883,7 +5883,7 @@
               </a:spcAft>
               <a:defRPr sz="1700">
                 <a:solidFill>
-                  <a:srgbClr val="FFFFFF"/>
+                  <a:srgbClr val="1A1A2E"/>
                 </a:solidFill>
               </a:defRPr>
             </a:pPr>
@@ -5907,7 +5907,7 @@
     <p:bg>
       <p:bgPr>
         <a:solidFill>
-          <a:srgbClr val="1A1A2E"/>
+          <a:srgbClr val="FFFFFF"/>
         </a:solidFill>
         <a:effectLst/>
       </p:bgPr>
@@ -5944,7 +5944,7 @@
             <a:pPr algn="l">
               <a:defRPr sz="3200" b="1">
                 <a:solidFill>
-                  <a:srgbClr val="FFFFFF"/>
+                  <a:srgbClr val="1565C0"/>
                 </a:solidFill>
               </a:defRPr>
             </a:pPr>
@@ -5969,7 +5969,7 @@
             <a:avLst/>
           </a:prstGeom>
           <a:solidFill>
-            <a:srgbClr val="006DAA"/>
+            <a:srgbClr val="1565C0"/>
           </a:solidFill>
           <a:ln>
             <a:noFill/>
@@ -6074,7 +6074,7 @@
             <a:pPr algn="r">
               <a:defRPr sz="1200" b="0">
                 <a:solidFill>
-                  <a:srgbClr val="666666"/>
+                  <a:srgbClr val="555555"/>
                 </a:solidFill>
               </a:defRPr>
             </a:pPr>
@@ -6112,7 +6112,7 @@
               </a:spcAft>
               <a:defRPr sz="1800">
                 <a:solidFill>
-                  <a:srgbClr val="FFFFFF"/>
+                  <a:srgbClr val="1A1A2E"/>
                 </a:solidFill>
               </a:defRPr>
             </a:pPr>
@@ -6127,7 +6127,7 @@
               </a:spcAft>
               <a:defRPr sz="1800">
                 <a:solidFill>
-                  <a:srgbClr val="FFFFFF"/>
+                  <a:srgbClr val="1A1A2E"/>
                 </a:solidFill>
               </a:defRPr>
             </a:pPr>
@@ -6139,7 +6139,7 @@
               </a:spcAft>
               <a:defRPr sz="1800">
                 <a:solidFill>
-                  <a:srgbClr val="FFFFFF"/>
+                  <a:srgbClr val="1A1A2E"/>
                 </a:solidFill>
               </a:defRPr>
             </a:pPr>
@@ -6154,7 +6154,7 @@
               </a:spcAft>
               <a:defRPr sz="1800">
                 <a:solidFill>
-                  <a:srgbClr val="FFFFFF"/>
+                  <a:srgbClr val="1A1A2E"/>
                 </a:solidFill>
               </a:defRPr>
             </a:pPr>
@@ -6166,7 +6166,7 @@
               </a:spcAft>
               <a:defRPr sz="1800">
                 <a:solidFill>
-                  <a:srgbClr val="FFFFFF"/>
+                  <a:srgbClr val="1A1A2E"/>
                 </a:solidFill>
               </a:defRPr>
             </a:pPr>
@@ -6181,7 +6181,7 @@
               </a:spcAft>
               <a:defRPr sz="1800">
                 <a:solidFill>
-                  <a:srgbClr val="FFFFFF"/>
+                  <a:srgbClr val="1A1A2E"/>
                 </a:solidFill>
               </a:defRPr>
             </a:pPr>
@@ -6193,7 +6193,7 @@
               </a:spcAft>
               <a:defRPr sz="1800">
                 <a:solidFill>
-                  <a:srgbClr val="FFFFFF"/>
+                  <a:srgbClr val="1A1A2E"/>
                 </a:solidFill>
               </a:defRPr>
             </a:pPr>
@@ -6208,7 +6208,7 @@
               </a:spcAft>
               <a:defRPr sz="1800">
                 <a:solidFill>
-                  <a:srgbClr val="FFFFFF"/>
+                  <a:srgbClr val="1A1A2E"/>
                 </a:solidFill>
               </a:defRPr>
             </a:pPr>
@@ -6223,7 +6223,7 @@
               </a:spcAft>
               <a:defRPr sz="1800">
                 <a:solidFill>
-                  <a:srgbClr val="FFFFFF"/>
+                  <a:srgbClr val="1A1A2E"/>
                 </a:solidFill>
               </a:defRPr>
             </a:pPr>
@@ -6238,7 +6238,7 @@
               </a:spcAft>
               <a:defRPr sz="1800">
                 <a:solidFill>
-                  <a:srgbClr val="FFFFFF"/>
+                  <a:srgbClr val="1A1A2E"/>
                 </a:solidFill>
               </a:defRPr>
             </a:pPr>
@@ -6253,7 +6253,7 @@
               </a:spcAft>
               <a:defRPr sz="1800">
                 <a:solidFill>
-                  <a:srgbClr val="FFFFFF"/>
+                  <a:srgbClr val="1A1A2E"/>
                 </a:solidFill>
               </a:defRPr>
             </a:pPr>
@@ -6265,7 +6265,7 @@
               </a:spcAft>
               <a:defRPr sz="1800">
                 <a:solidFill>
-                  <a:srgbClr val="FFFFFF"/>
+                  <a:srgbClr val="1A1A2E"/>
                 </a:solidFill>
               </a:defRPr>
             </a:pPr>
@@ -6289,7 +6289,7 @@
     <p:bg>
       <p:bgPr>
         <a:solidFill>
-          <a:srgbClr val="1A1A2E"/>
+          <a:srgbClr val="FFFFFF"/>
         </a:solidFill>
         <a:effectLst/>
       </p:bgPr>
@@ -6326,7 +6326,7 @@
             <a:pPr algn="l">
               <a:defRPr sz="3200" b="1">
                 <a:solidFill>
-                  <a:srgbClr val="FFFFFF"/>
+                  <a:srgbClr val="1565C0"/>
                 </a:solidFill>
               </a:defRPr>
             </a:pPr>
@@ -6351,7 +6351,7 @@
             <a:avLst/>
           </a:prstGeom>
           <a:solidFill>
-            <a:srgbClr val="006DAA"/>
+            <a:srgbClr val="1565C0"/>
           </a:solidFill>
           <a:ln>
             <a:noFill/>
@@ -6456,7 +6456,7 @@
             <a:pPr algn="r">
               <a:defRPr sz="1200" b="0">
                 <a:solidFill>
-                  <a:srgbClr val="666666"/>
+                  <a:srgbClr val="555555"/>
                 </a:solidFill>
               </a:defRPr>
             </a:pPr>
@@ -6494,7 +6494,7 @@
               </a:spcAft>
               <a:defRPr sz="1800">
                 <a:solidFill>
-                  <a:srgbClr val="FFFFFF"/>
+                  <a:srgbClr val="1A1A2E"/>
                 </a:solidFill>
               </a:defRPr>
             </a:pPr>
@@ -6509,7 +6509,7 @@
               </a:spcAft>
               <a:defRPr sz="1800">
                 <a:solidFill>
-                  <a:srgbClr val="FFFFFF"/>
+                  <a:srgbClr val="1A1A2E"/>
                 </a:solidFill>
               </a:defRPr>
             </a:pPr>
@@ -6524,7 +6524,7 @@
               </a:spcAft>
               <a:defRPr sz="1800">
                 <a:solidFill>
-                  <a:srgbClr val="FFFFFF"/>
+                  <a:srgbClr val="1A1A2E"/>
                 </a:solidFill>
               </a:defRPr>
             </a:pPr>
@@ -6539,7 +6539,7 @@
               </a:spcAft>
               <a:defRPr sz="1800">
                 <a:solidFill>
-                  <a:srgbClr val="FFFFFF"/>
+                  <a:srgbClr val="1A1A2E"/>
                 </a:solidFill>
               </a:defRPr>
             </a:pPr>
@@ -6554,7 +6554,7 @@
               </a:spcAft>
               <a:defRPr sz="1800">
                 <a:solidFill>
-                  <a:srgbClr val="FFFFFF"/>
+                  <a:srgbClr val="1A1A2E"/>
                 </a:solidFill>
               </a:defRPr>
             </a:pPr>
@@ -6566,7 +6566,7 @@
               </a:spcAft>
               <a:defRPr sz="1800">
                 <a:solidFill>
-                  <a:srgbClr val="FFFFFF"/>
+                  <a:srgbClr val="1A1A2E"/>
                 </a:solidFill>
               </a:defRPr>
             </a:pPr>
@@ -6581,7 +6581,7 @@
               </a:spcAft>
               <a:defRPr sz="1800">
                 <a:solidFill>
-                  <a:srgbClr val="FFFFFF"/>
+                  <a:srgbClr val="1A1A2E"/>
                 </a:solidFill>
               </a:defRPr>
             </a:pPr>
@@ -6596,7 +6596,7 @@
               </a:spcAft>
               <a:defRPr sz="1800">
                 <a:solidFill>
-                  <a:srgbClr val="FFFFFF"/>
+                  <a:srgbClr val="1A1A2E"/>
                 </a:solidFill>
               </a:defRPr>
             </a:pPr>
@@ -6611,7 +6611,7 @@
               </a:spcAft>
               <a:defRPr sz="1800">
                 <a:solidFill>
-                  <a:srgbClr val="FFFFFF"/>
+                  <a:srgbClr val="1A1A2E"/>
                 </a:solidFill>
               </a:defRPr>
             </a:pPr>
@@ -6623,7 +6623,7 @@
               </a:spcAft>
               <a:defRPr sz="1800">
                 <a:solidFill>
-                  <a:srgbClr val="FFFFFF"/>
+                  <a:srgbClr val="1A1A2E"/>
                 </a:solidFill>
               </a:defRPr>
             </a:pPr>
@@ -6638,7 +6638,7 @@
               </a:spcAft>
               <a:defRPr sz="1800">
                 <a:solidFill>
-                  <a:srgbClr val="FFFFFF"/>
+                  <a:srgbClr val="1A1A2E"/>
                 </a:solidFill>
               </a:defRPr>
             </a:pPr>
@@ -6653,7 +6653,7 @@
               </a:spcAft>
               <a:defRPr sz="1800">
                 <a:solidFill>
-                  <a:srgbClr val="FFFFFF"/>
+                  <a:srgbClr val="1A1A2E"/>
                 </a:solidFill>
               </a:defRPr>
             </a:pPr>
@@ -6668,7 +6668,7 @@
               </a:spcAft>
               <a:defRPr sz="1800">
                 <a:solidFill>
-                  <a:srgbClr val="FFFFFF"/>
+                  <a:srgbClr val="1A1A2E"/>
                 </a:solidFill>
               </a:defRPr>
             </a:pPr>
@@ -6680,7 +6680,7 @@
               </a:spcAft>
               <a:defRPr sz="1800">
                 <a:solidFill>
-                  <a:srgbClr val="FFFFFF"/>
+                  <a:srgbClr val="1A1A2E"/>
                 </a:solidFill>
               </a:defRPr>
             </a:pPr>
@@ -6704,7 +6704,7 @@
     <p:bg>
       <p:bgPr>
         <a:solidFill>
-          <a:srgbClr val="1A1A2E"/>
+          <a:srgbClr val="FFFFFF"/>
         </a:solidFill>
         <a:effectLst/>
       </p:bgPr>
@@ -6741,7 +6741,7 @@
             <a:pPr algn="l">
               <a:defRPr sz="3200" b="1">
                 <a:solidFill>
-                  <a:srgbClr val="FFFFFF"/>
+                  <a:srgbClr val="1565C0"/>
                 </a:solidFill>
               </a:defRPr>
             </a:pPr>
@@ -6766,7 +6766,7 @@
             <a:avLst/>
           </a:prstGeom>
           <a:solidFill>
-            <a:srgbClr val="006DAA"/>
+            <a:srgbClr val="1565C0"/>
           </a:solidFill>
           <a:ln>
             <a:noFill/>
@@ -6871,7 +6871,7 @@
             <a:pPr algn="r">
               <a:defRPr sz="1200" b="0">
                 <a:solidFill>
-                  <a:srgbClr val="666666"/>
+                  <a:srgbClr val="555555"/>
                 </a:solidFill>
               </a:defRPr>
             </a:pPr>
@@ -6909,7 +6909,7 @@
               </a:spcAft>
               <a:defRPr sz="1800">
                 <a:solidFill>
-                  <a:srgbClr val="FFFFFF"/>
+                  <a:srgbClr val="1A1A2E"/>
                 </a:solidFill>
               </a:defRPr>
             </a:pPr>
@@ -6924,7 +6924,7 @@
               </a:spcAft>
               <a:defRPr sz="1800">
                 <a:solidFill>
-                  <a:srgbClr val="FFFFFF"/>
+                  <a:srgbClr val="1A1A2E"/>
                 </a:solidFill>
               </a:defRPr>
             </a:pPr>
@@ -6936,7 +6936,7 @@
               </a:spcAft>
               <a:defRPr sz="1800">
                 <a:solidFill>
-                  <a:srgbClr val="FFFFFF"/>
+                  <a:srgbClr val="1A1A2E"/>
                 </a:solidFill>
               </a:defRPr>
             </a:pPr>
@@ -6951,7 +6951,7 @@
               </a:spcAft>
               <a:defRPr sz="1800">
                 <a:solidFill>
-                  <a:srgbClr val="FFFFFF"/>
+                  <a:srgbClr val="1A1A2E"/>
                 </a:solidFill>
               </a:defRPr>
             </a:pPr>
@@ -6963,7 +6963,7 @@
               </a:spcAft>
               <a:defRPr sz="1800">
                 <a:solidFill>
-                  <a:srgbClr val="FFFFFF"/>
+                  <a:srgbClr val="1A1A2E"/>
                 </a:solidFill>
               </a:defRPr>
             </a:pPr>
@@ -6978,7 +6978,7 @@
               </a:spcAft>
               <a:defRPr sz="1800">
                 <a:solidFill>
-                  <a:srgbClr val="FFFFFF"/>
+                  <a:srgbClr val="1A1A2E"/>
                 </a:solidFill>
               </a:defRPr>
             </a:pPr>
@@ -6993,7 +6993,7 @@
               </a:spcAft>
               <a:defRPr sz="1800">
                 <a:solidFill>
-                  <a:srgbClr val="FFFFFF"/>
+                  <a:srgbClr val="1A1A2E"/>
                 </a:solidFill>
               </a:defRPr>
             </a:pPr>
@@ -7008,7 +7008,7 @@
               </a:spcAft>
               <a:defRPr sz="1800">
                 <a:solidFill>
-                  <a:srgbClr val="FFFFFF"/>
+                  <a:srgbClr val="1A1A2E"/>
                 </a:solidFill>
               </a:defRPr>
             </a:pPr>
@@ -7020,7 +7020,7 @@
               </a:spcAft>
               <a:defRPr sz="1800">
                 <a:solidFill>
-                  <a:srgbClr val="FFFFFF"/>
+                  <a:srgbClr val="1A1A2E"/>
                 </a:solidFill>
               </a:defRPr>
             </a:pPr>
@@ -7035,7 +7035,7 @@
               </a:spcAft>
               <a:defRPr sz="1800">
                 <a:solidFill>
-                  <a:srgbClr val="FFFFFF"/>
+                  <a:srgbClr val="1A1A2E"/>
                 </a:solidFill>
               </a:defRPr>
             </a:pPr>
@@ -7047,7 +7047,7 @@
               </a:spcAft>
               <a:defRPr sz="1800">
                 <a:solidFill>
-                  <a:srgbClr val="FFFFFF"/>
+                  <a:srgbClr val="1A1A2E"/>
                 </a:solidFill>
               </a:defRPr>
             </a:pPr>
@@ -7062,7 +7062,7 @@
               </a:spcAft>
               <a:defRPr sz="1800">
                 <a:solidFill>
-                  <a:srgbClr val="FFFFFF"/>
+                  <a:srgbClr val="1A1A2E"/>
                 </a:solidFill>
               </a:defRPr>
             </a:pPr>
@@ -7077,7 +7077,7 @@
               </a:spcAft>
               <a:defRPr sz="1800">
                 <a:solidFill>
-                  <a:srgbClr val="FFFFFF"/>
+                  <a:srgbClr val="1A1A2E"/>
                 </a:solidFill>
               </a:defRPr>
             </a:pPr>
@@ -7089,7 +7089,7 @@
               </a:spcAft>
               <a:defRPr sz="1800">
                 <a:solidFill>
-                  <a:srgbClr val="FFFFFF"/>
+                  <a:srgbClr val="1A1A2E"/>
                 </a:solidFill>
               </a:defRPr>
             </a:pPr>
@@ -7113,7 +7113,7 @@
     <p:bg>
       <p:bgPr>
         <a:solidFill>
-          <a:srgbClr val="1A1A2E"/>
+          <a:srgbClr val="FFFFFF"/>
         </a:solidFill>
         <a:effectLst/>
       </p:bgPr>
@@ -7150,7 +7150,7 @@
             <a:pPr algn="l">
               <a:defRPr sz="3200" b="1">
                 <a:solidFill>
-                  <a:srgbClr val="FFFFFF"/>
+                  <a:srgbClr val="1565C0"/>
                 </a:solidFill>
               </a:defRPr>
             </a:pPr>
@@ -7280,7 +7280,7 @@
             <a:pPr algn="r">
               <a:defRPr sz="1200" b="0">
                 <a:solidFill>
-                  <a:srgbClr val="666666"/>
+                  <a:srgbClr val="555555"/>
                 </a:solidFill>
               </a:defRPr>
             </a:pPr>
@@ -7318,7 +7318,7 @@
               </a:spcAft>
               <a:defRPr sz="2000">
                 <a:solidFill>
-                  <a:srgbClr val="FFFFFF"/>
+                  <a:srgbClr val="1A1A2E"/>
                 </a:solidFill>
               </a:defRPr>
             </a:pPr>
@@ -7333,7 +7333,7 @@
               </a:spcAft>
               <a:defRPr sz="2000">
                 <a:solidFill>
-                  <a:srgbClr val="FFFFFF"/>
+                  <a:srgbClr val="1A1A2E"/>
                 </a:solidFill>
               </a:defRPr>
             </a:pPr>
@@ -7348,7 +7348,7 @@
               </a:spcAft>
               <a:defRPr sz="2000">
                 <a:solidFill>
-                  <a:srgbClr val="FFFFFF"/>
+                  <a:srgbClr val="1A1A2E"/>
                 </a:solidFill>
               </a:defRPr>
             </a:pPr>
@@ -7360,7 +7360,7 @@
               </a:spcAft>
               <a:defRPr sz="2000">
                 <a:solidFill>
-                  <a:srgbClr val="FFFFFF"/>
+                  <a:srgbClr val="1A1A2E"/>
                 </a:solidFill>
               </a:defRPr>
             </a:pPr>
@@ -7375,7 +7375,7 @@
               </a:spcAft>
               <a:defRPr sz="2000">
                 <a:solidFill>
-                  <a:srgbClr val="FFFFFF"/>
+                  <a:srgbClr val="1A1A2E"/>
                 </a:solidFill>
               </a:defRPr>
             </a:pPr>
@@ -7390,7 +7390,7 @@
               </a:spcAft>
               <a:defRPr sz="2000">
                 <a:solidFill>
-                  <a:srgbClr val="FFFFFF"/>
+                  <a:srgbClr val="1A1A2E"/>
                 </a:solidFill>
               </a:defRPr>
             </a:pPr>
@@ -7402,7 +7402,7 @@
               </a:spcAft>
               <a:defRPr sz="2000">
                 <a:solidFill>
-                  <a:srgbClr val="FFFFFF"/>
+                  <a:srgbClr val="1A1A2E"/>
                 </a:solidFill>
               </a:defRPr>
             </a:pPr>
@@ -7417,7 +7417,7 @@
               </a:spcAft>
               <a:defRPr sz="2000">
                 <a:solidFill>
-                  <a:srgbClr val="FFFFFF"/>
+                  <a:srgbClr val="1A1A2E"/>
                 </a:solidFill>
               </a:defRPr>
             </a:pPr>
@@ -7432,7 +7432,7 @@
               </a:spcAft>
               <a:defRPr sz="2000">
                 <a:solidFill>
-                  <a:srgbClr val="FFFFFF"/>
+                  <a:srgbClr val="1A1A2E"/>
                 </a:solidFill>
               </a:defRPr>
             </a:pPr>
@@ -7444,7 +7444,7 @@
               </a:spcAft>
               <a:defRPr sz="2000">
                 <a:solidFill>
-                  <a:srgbClr val="FFFFFF"/>
+                  <a:srgbClr val="1A1A2E"/>
                 </a:solidFill>
               </a:defRPr>
             </a:pPr>
@@ -7459,7 +7459,7 @@
               </a:spcAft>
               <a:defRPr sz="2000">
                 <a:solidFill>
-                  <a:srgbClr val="FFFFFF"/>
+                  <a:srgbClr val="1A1A2E"/>
                 </a:solidFill>
               </a:defRPr>
             </a:pPr>

</xml_diff>